<commit_message>
Polish project documentation and presentation properties
</commit_message>
<xml_diff>
--- a/presentation/output/HeroVired_Capstone_Sanket_Toche.pptx
+++ b/presentation/output/HeroVired_Capstone_Sanket_Toche.pptx
@@ -165,9 +165,9 @@
 </file>
 
 <file path=ppt/notesMasters/theme/theme3.xml><?xml version="1.0" encoding="utf-8"?>
-<a:theme xmlns:a="http://schemas.openxmlformats.org/drawingml/2006/main" name="ChatGPT">
+<a:theme xmlns:a="http://schemas.openxmlformats.org/drawingml/2006/main" name="HeroVired">
   <a:themeElements>
-    <a:clrScheme name="ChatGPT">
+    <a:clrScheme name="HeroVired">
       <a:dk1>
         <a:srgbClr val="000000"/>
       </a:dk1>
@@ -217,7 +217,7 @@
         <a:cs typeface=""/>
       </a:minorFont>
     </a:fontScheme>
-    <a:fmtScheme name="ChatGPT">
+    <a:fmtScheme name="HeroVired">
       <a:fillStyleLst>
         <a:solidFill>
           <a:schemeClr val="phClr"/>
@@ -3750,9 +3750,9 @@
 </file>
 
 <file path=ppt/slideMasters/theme/theme2.xml><?xml version="1.0" encoding="utf-8"?>
-<a:theme xmlns:a="http://schemas.openxmlformats.org/drawingml/2006/main" name="ChatGPT">
+<a:theme xmlns:a="http://schemas.openxmlformats.org/drawingml/2006/main" name="HeroVired">
   <a:themeElements>
-    <a:clrScheme name="ChatGPT">
+    <a:clrScheme name="HeroVired">
       <a:dk1>
         <a:srgbClr val="000000"/>
       </a:dk1>
@@ -3802,7 +3802,7 @@
         <a:cs typeface=""/>
       </a:minorFont>
     </a:fontScheme>
-    <a:fmtScheme name="ChatGPT">
+    <a:fmtScheme name="HeroVired">
       <a:fillStyleLst>
         <a:solidFill>
           <a:schemeClr val="phClr"/>
@@ -17214,9 +17214,9 @@
 </file>
 
 <file path=ppt/theme/theme1.xml><?xml version="1.0" encoding="utf-8"?>
-<a:theme xmlns:a="http://schemas.openxmlformats.org/drawingml/2006/main" name="ChatGPT">
+<a:theme xmlns:a="http://schemas.openxmlformats.org/drawingml/2006/main" name="HeroVired">
   <a:themeElements>
-    <a:clrScheme name="ChatGPT">
+    <a:clrScheme name="HeroVired">
       <a:dk1>
         <a:srgbClr val="000000"/>
       </a:dk1>
@@ -17266,7 +17266,7 @@
         <a:cs typeface=""/>
       </a:minorFont>
     </a:fontScheme>
-    <a:fmtScheme name="ChatGPT">
+    <a:fmtScheme name="HeroVired">
       <a:fillStyleLst>
         <a:solidFill>
           <a:schemeClr val="phClr"/>

</xml_diff>